<commit_message>
docs(w3): add midterm talk track and qa
</commit_message>
<xml_diff>
--- a/reports/p1_midterm_slides.pptx
+++ b/reports/p1_midterm_slides.pptx
@@ -16,6 +16,8 @@
     <p:sldId id="264" r:id="rId15"/>
     <p:sldId id="265" r:id="rId16"/>
     <p:sldId id="266" r:id="rId17"/>
+    <p:sldId id="267" r:id="rId18"/>
+    <p:sldId id="268" r:id="rId19"/>
   </p:sldIdLst>
   <p:sldSz cx="12191695" cy="6858000" type="screen4x3"/>
   <p:notesSz cx="6858000" cy="9144000"/>
@@ -4236,6 +4238,796 @@
                 </a:solidFill>
               </a:rPr>
               <a:t>11</a:t>
+            </a:r>
+          </a:p>
+        </p:txBody>
+      </p:sp>
+    </p:spTree>
+  </p:cSld>
+  <p:clrMapOvr>
+    <a:masterClrMapping/>
+  </p:clrMapOvr>
+</p:sld>
+</file>
+
+<file path=ppt/slides/slide12.xml><?xml version="1.0" encoding="utf-8"?>
+<p:sld xmlns:a="http://schemas.openxmlformats.org/drawingml/2006/main" xmlns:p="http://schemas.openxmlformats.org/presentationml/2006/main" xmlns:r="http://schemas.openxmlformats.org/officeDocument/2006/relationships">
+  <p:cSld>
+    <p:bg>
+      <p:bgPr>
+        <a:solidFill>
+          <a:srgbClr val="FFFFFF"/>
+        </a:solidFill>
+        <a:effectLst/>
+      </p:bgPr>
+    </p:bg>
+    <p:spTree>
+      <p:nvGrpSpPr>
+        <p:cNvPr id="1" name=""/>
+        <p:cNvGrpSpPr/>
+        <p:nvPr/>
+      </p:nvGrpSpPr>
+      <p:grpSpPr/>
+      <p:sp>
+        <p:nvSpPr>
+          <p:cNvPr id="2" name="TextBox 1"/>
+          <p:cNvSpPr txBox="1"/>
+          <p:nvPr/>
+        </p:nvSpPr>
+        <p:spPr>
+          <a:xfrm>
+            <a:off x="502920" y="256032"/>
+            <a:ext cx="10881360" cy="411480"/>
+          </a:xfrm>
+          <a:prstGeom prst="rect">
+            <a:avLst/>
+          </a:prstGeom>
+          <a:noFill/>
+        </p:spPr>
+        <p:txBody>
+          <a:bodyPr wrap="none">
+            <a:spAutoFit/>
+          </a:bodyPr>
+          <a:lstStyle/>
+          <a:p>
+            <a:r>
+              <a:rPr sz="2400" b="1">
+                <a:solidFill>
+                  <a:srgbClr val="17202A"/>
+                </a:solidFill>
+              </a:rPr>
+              <a:t>Appendix A:答辩 Q&amp;A 速记</a:t>
+            </a:r>
+          </a:p>
+        </p:txBody>
+      </p:sp>
+      <p:sp>
+        <p:nvSpPr>
+          <p:cNvPr id="3" name="Rectangle 2"/>
+          <p:cNvSpPr/>
+          <p:nvPr/>
+        </p:nvSpPr>
+        <p:spPr>
+          <a:xfrm>
+            <a:off x="502920" y="987552"/>
+            <a:ext cx="11064240" cy="9144"/>
+          </a:xfrm>
+          <a:prstGeom prst="rect">
+            <a:avLst/>
+          </a:prstGeom>
+          <a:solidFill>
+            <a:srgbClr val="D9E1EA"/>
+          </a:solidFill>
+          <a:ln>
+            <a:noFill/>
+          </a:ln>
+        </p:spPr>
+        <p:style>
+          <a:lnRef idx="1">
+            <a:schemeClr val="accent1"/>
+          </a:lnRef>
+          <a:fillRef idx="3">
+            <a:schemeClr val="accent1"/>
+          </a:fillRef>
+          <a:effectRef idx="2">
+            <a:schemeClr val="accent1"/>
+          </a:effectRef>
+          <a:fontRef idx="minor">
+            <a:schemeClr val="lt1"/>
+          </a:fontRef>
+        </p:style>
+        <p:txBody>
+          <a:bodyPr rtlCol="0" anchor="ctr"/>
+          <a:lstStyle/>
+          <a:p>
+            <a:pPr algn="ctr"/>
+          </a:p>
+        </p:txBody>
+      </p:sp>
+      <p:sp>
+        <p:nvSpPr>
+          <p:cNvPr id="4" name="TextBox 3"/>
+          <p:cNvSpPr txBox="1"/>
+          <p:nvPr/>
+        </p:nvSpPr>
+        <p:spPr>
+          <a:xfrm>
+            <a:off x="777240" y="1188720"/>
+            <a:ext cx="5303520" cy="4480560"/>
+          </a:xfrm>
+          <a:prstGeom prst="rect">
+            <a:avLst/>
+          </a:prstGeom>
+          <a:noFill/>
+        </p:spPr>
+        <p:txBody>
+          <a:bodyPr wrap="square">
+            <a:spAutoFit/>
+          </a:bodyPr>
+          <a:lstStyle/>
+          <a:p>
+            <a:pPr>
+              <a:lnSpc>
+                <a:spcPct val="110000"/>
+              </a:lnSpc>
+              <a:spcAft>
+                <a:spcPts val="700"/>
+              </a:spcAft>
+              <a:defRPr sz="1550">
+                <a:solidFill>
+                  <a:srgbClr val="17202A"/>
+                </a:solidFill>
+              </a:defRPr>
+            </a:pPr>
+            <a:r>
+              <a:t>为什么 Spark 没赢? 小表格训练/单样本推理阶段调度开销大。</a:t>
+            </a:r>
+          </a:p>
+          <a:p>
+            <a:pPr>
+              <a:lnSpc>
+                <a:spcPct val="110000"/>
+              </a:lnSpc>
+              <a:spcAft>
+                <a:spcPts val="700"/>
+              </a:spcAft>
+              <a:defRPr sz="1550">
+                <a:solidFill>
+                  <a:srgbClr val="17202A"/>
+                </a:solidFill>
+              </a:defRPr>
+            </a:pPr>
+            <a:r>
+              <a:t>为什么仍说 Spark 价值在 ETL? actigraphy 有约 3.15 亿行,特征阶段才有大数据量。</a:t>
+            </a:r>
+          </a:p>
+          <a:p>
+            <a:pPr>
+              <a:lnSpc>
+                <a:spcPct val="110000"/>
+              </a:lnSpc>
+              <a:spcAft>
+                <a:spcPts val="700"/>
+              </a:spcAft>
+              <a:defRPr sz="1550">
+                <a:solidFill>
+                  <a:srgbClr val="17202A"/>
+                </a:solidFill>
+              </a:defRPr>
+            </a:pPr>
+            <a:r>
+              <a:t>为什么 feat_v2 没提升? 有标签样本 actigraphy 覆盖率只有 36.4%,fold 4 子集无 class 3。</a:t>
+            </a:r>
+          </a:p>
+          <a:p>
+            <a:pPr>
+              <a:lnSpc>
+                <a:spcPct val="110000"/>
+              </a:lnSpc>
+              <a:spcAft>
+                <a:spcPts val="700"/>
+              </a:spcAft>
+              <a:defRPr sz="1550">
+                <a:solidFill>
+                  <a:srgbClr val="17202A"/>
+                </a:solidFill>
+              </a:defRPr>
+            </a:pPr>
+            <a:r>
+              <a:t>为什么不用 actigraphy 子集替代主表? 样本协议改变,类别更稀疏,只能作补充分析。</a:t>
+            </a:r>
+          </a:p>
+        </p:txBody>
+      </p:sp>
+      <p:sp>
+        <p:nvSpPr>
+          <p:cNvPr id="5" name="TextBox 4"/>
+          <p:cNvSpPr txBox="1"/>
+          <p:nvPr/>
+        </p:nvSpPr>
+        <p:spPr>
+          <a:xfrm>
+            <a:off x="6400800" y="1188720"/>
+            <a:ext cx="4937760" cy="4480560"/>
+          </a:xfrm>
+          <a:prstGeom prst="rect">
+            <a:avLst/>
+          </a:prstGeom>
+          <a:noFill/>
+        </p:spPr>
+        <p:txBody>
+          <a:bodyPr wrap="square">
+            <a:spAutoFit/>
+          </a:bodyPr>
+          <a:lstStyle/>
+          <a:p>
+            <a:pPr>
+              <a:lnSpc>
+                <a:spcPct val="110000"/>
+              </a:lnSpc>
+              <a:spcAft>
+                <a:spcPts val="700"/>
+              </a:spcAft>
+              <a:defRPr sz="1550">
+                <a:solidFill>
+                  <a:srgbClr val="5F6B7A"/>
+                </a:solidFill>
+              </a:defRPr>
+            </a:pPr>
+            <a:r>
+              <a:t>A6 为什么越并行越慢? 瓶颈更像 shuffle/序列化/Python worker 调度和尾部任务。</a:t>
+            </a:r>
+          </a:p>
+          <a:p>
+            <a:pPr>
+              <a:lnSpc>
+                <a:spcPct val="110000"/>
+              </a:lnSpc>
+              <a:spcAft>
+                <a:spcPts val="700"/>
+              </a:spcAft>
+              <a:defRPr sz="1550">
+                <a:solidFill>
+                  <a:srgbClr val="5F6B7A"/>
+                </a:solidFill>
+              </a:defRPr>
+            </a:pPr>
+            <a:r>
+              <a:t>公平性怎么保证? 同 feature、fold、seed、预处理;imputer/scaler 只在训练 fold fit。</a:t>
+            </a:r>
+          </a:p>
+          <a:p>
+            <a:pPr>
+              <a:lnSpc>
+                <a:spcPct val="110000"/>
+              </a:lnSpc>
+              <a:spcAft>
+                <a:spcPts val="700"/>
+              </a:spcAft>
+              <a:defRPr sz="1550">
+                <a:solidFill>
+                  <a:srgbClr val="5F6B7A"/>
+                </a:solidFill>
+              </a:defRPr>
+            </a:pPr>
+            <a:r>
+              <a:t>P2 怎么衔接? 选择稳定低延迟模型,做注册、服务化、监控和发布。</a:t>
+            </a:r>
+          </a:p>
+          <a:p>
+            <a:pPr>
+              <a:lnSpc>
+                <a:spcPct val="110000"/>
+              </a:lnSpc>
+              <a:spcAft>
+                <a:spcPts val="700"/>
+              </a:spcAft>
+              <a:defRPr sz="1550">
+                <a:solidFill>
+                  <a:srgbClr val="5F6B7A"/>
+                </a:solidFill>
+              </a:defRPr>
+            </a:pPr>
+            <a:r>
+              <a:t>完整回答见:00_docs/P1_MIDTERM_QA.md</a:t>
+            </a:r>
+          </a:p>
+        </p:txBody>
+      </p:sp>
+      <p:sp>
+        <p:nvSpPr>
+          <p:cNvPr id="6" name="TextBox 5"/>
+          <p:cNvSpPr txBox="1"/>
+          <p:nvPr/>
+        </p:nvSpPr>
+        <p:spPr>
+          <a:xfrm>
+            <a:off x="502920" y="6510528"/>
+            <a:ext cx="4754880" cy="201168"/>
+          </a:xfrm>
+          <a:prstGeom prst="rect">
+            <a:avLst/>
+          </a:prstGeom>
+          <a:noFill/>
+        </p:spPr>
+        <p:txBody>
+          <a:bodyPr wrap="none">
+            <a:spAutoFit/>
+          </a:bodyPr>
+          <a:lstStyle/>
+          <a:p>
+            <a:r>
+              <a:rPr sz="850" b="0">
+                <a:solidFill>
+                  <a:srgbClr val="5F6B7A"/>
+                </a:solidFill>
+              </a:rPr>
+              <a:t>MLsystem P1 midterm | PIU multi-system comparison</a:t>
+            </a:r>
+          </a:p>
+        </p:txBody>
+      </p:sp>
+      <p:sp>
+        <p:nvSpPr>
+          <p:cNvPr id="7" name="TextBox 6"/>
+          <p:cNvSpPr txBox="1"/>
+          <p:nvPr/>
+        </p:nvSpPr>
+        <p:spPr>
+          <a:xfrm>
+            <a:off x="11201400" y="6510528"/>
+            <a:ext cx="502920" cy="201168"/>
+          </a:xfrm>
+          <a:prstGeom prst="rect">
+            <a:avLst/>
+          </a:prstGeom>
+          <a:noFill/>
+        </p:spPr>
+        <p:txBody>
+          <a:bodyPr wrap="none">
+            <a:spAutoFit/>
+          </a:bodyPr>
+          <a:lstStyle/>
+          <a:p>
+            <a:pPr algn="r"/>
+            <a:r>
+              <a:rPr sz="850" b="0">
+                <a:solidFill>
+                  <a:srgbClr val="5F6B7A"/>
+                </a:solidFill>
+              </a:rPr>
+              <a:t>12</a:t>
+            </a:r>
+          </a:p>
+        </p:txBody>
+      </p:sp>
+    </p:spTree>
+  </p:cSld>
+  <p:clrMapOvr>
+    <a:masterClrMapping/>
+  </p:clrMapOvr>
+</p:sld>
+</file>
+
+<file path=ppt/slides/slide13.xml><?xml version="1.0" encoding="utf-8"?>
+<p:sld xmlns:a="http://schemas.openxmlformats.org/drawingml/2006/main" xmlns:p="http://schemas.openxmlformats.org/presentationml/2006/main" xmlns:r="http://schemas.openxmlformats.org/officeDocument/2006/relationships">
+  <p:cSld>
+    <p:bg>
+      <p:bgPr>
+        <a:solidFill>
+          <a:srgbClr val="FFFFFF"/>
+        </a:solidFill>
+        <a:effectLst/>
+      </p:bgPr>
+    </p:bg>
+    <p:spTree>
+      <p:nvGrpSpPr>
+        <p:cNvPr id="1" name=""/>
+        <p:cNvGrpSpPr/>
+        <p:nvPr/>
+      </p:nvGrpSpPr>
+      <p:grpSpPr/>
+      <p:sp>
+        <p:nvSpPr>
+          <p:cNvPr id="2" name="TextBox 1"/>
+          <p:cNvSpPr txBox="1"/>
+          <p:nvPr/>
+        </p:nvSpPr>
+        <p:spPr>
+          <a:xfrm>
+            <a:off x="502920" y="256032"/>
+            <a:ext cx="10881360" cy="411480"/>
+          </a:xfrm>
+          <a:prstGeom prst="rect">
+            <a:avLst/>
+          </a:prstGeom>
+          <a:noFill/>
+        </p:spPr>
+        <p:txBody>
+          <a:bodyPr wrap="none">
+            <a:spAutoFit/>
+          </a:bodyPr>
+          <a:lstStyle/>
+          <a:p>
+            <a:r>
+              <a:rPr sz="2400" b="1">
+                <a:solidFill>
+                  <a:srgbClr val="17202A"/>
+                </a:solidFill>
+              </a:rPr>
+              <a:t>Appendix B:复现命令与材料路径</a:t>
+            </a:r>
+          </a:p>
+        </p:txBody>
+      </p:sp>
+      <p:sp>
+        <p:nvSpPr>
+          <p:cNvPr id="3" name="Rectangle 2"/>
+          <p:cNvSpPr/>
+          <p:nvPr/>
+        </p:nvSpPr>
+        <p:spPr>
+          <a:xfrm>
+            <a:off x="502920" y="987552"/>
+            <a:ext cx="11064240" cy="9144"/>
+          </a:xfrm>
+          <a:prstGeom prst="rect">
+            <a:avLst/>
+          </a:prstGeom>
+          <a:solidFill>
+            <a:srgbClr val="D9E1EA"/>
+          </a:solidFill>
+          <a:ln>
+            <a:noFill/>
+          </a:ln>
+        </p:spPr>
+        <p:style>
+          <a:lnRef idx="1">
+            <a:schemeClr val="accent1"/>
+          </a:lnRef>
+          <a:fillRef idx="3">
+            <a:schemeClr val="accent1"/>
+          </a:fillRef>
+          <a:effectRef idx="2">
+            <a:schemeClr val="accent1"/>
+          </a:effectRef>
+          <a:fontRef idx="minor">
+            <a:schemeClr val="lt1"/>
+          </a:fontRef>
+        </p:style>
+        <p:txBody>
+          <a:bodyPr rtlCol="0" anchor="ctr"/>
+          <a:lstStyle/>
+          <a:p>
+            <a:pPr algn="ctr"/>
+          </a:p>
+        </p:txBody>
+      </p:sp>
+      <p:sp>
+        <p:nvSpPr>
+          <p:cNvPr id="4" name="TextBox 3"/>
+          <p:cNvSpPr txBox="1"/>
+          <p:nvPr/>
+        </p:nvSpPr>
+        <p:spPr>
+          <a:xfrm>
+            <a:off x="777240" y="1143000"/>
+            <a:ext cx="5303520" cy="4526280"/>
+          </a:xfrm>
+          <a:prstGeom prst="rect">
+            <a:avLst/>
+          </a:prstGeom>
+          <a:noFill/>
+        </p:spPr>
+        <p:txBody>
+          <a:bodyPr wrap="square">
+            <a:spAutoFit/>
+          </a:bodyPr>
+          <a:lstStyle/>
+          <a:p>
+            <a:pPr>
+              <a:lnSpc>
+                <a:spcPct val="110000"/>
+              </a:lnSpc>
+              <a:spcAft>
+                <a:spcPts val="700"/>
+              </a:spcAft>
+              <a:defRPr sz="1350">
+                <a:solidFill>
+                  <a:srgbClr val="17202A"/>
+                </a:solidFill>
+              </a:defRPr>
+            </a:pPr>
+            <a:r>
+              <a:t>Table 1: python -m src.experiments.run_p1_feature_stage --mlflow</a:t>
+            </a:r>
+          </a:p>
+          <a:p>
+            <a:pPr>
+              <a:lnSpc>
+                <a:spcPct val="110000"/>
+              </a:lnSpc>
+              <a:spcAft>
+                <a:spcPts val="700"/>
+              </a:spcAft>
+              <a:defRPr sz="1350">
+                <a:solidFill>
+                  <a:srgbClr val="17202A"/>
+                </a:solidFill>
+              </a:defRPr>
+            </a:pPr>
+            <a:r>
+              <a:t>Table 2: python -m src.experiments.run_p1_systemwise --feature v2 --mlflow</a:t>
+            </a:r>
+          </a:p>
+          <a:p>
+            <a:pPr>
+              <a:lnSpc>
+                <a:spcPct val="110000"/>
+              </a:lnSpc>
+              <a:spcAft>
+                <a:spcPts val="700"/>
+              </a:spcAft>
+              <a:defRPr sz="1350">
+                <a:solidFill>
+                  <a:srgbClr val="17202A"/>
+                </a:solidFill>
+              </a:defRPr>
+            </a:pPr>
+            <a:r>
+              <a:t>A5: python -m src.experiments.run_p1_ablation_a5_coverage</a:t>
+            </a:r>
+          </a:p>
+          <a:p>
+            <a:pPr>
+              <a:lnSpc>
+                <a:spcPct val="110000"/>
+              </a:lnSpc>
+              <a:spcAft>
+                <a:spcPts val="700"/>
+              </a:spcAft>
+              <a:defRPr sz="1350">
+                <a:solidFill>
+                  <a:srgbClr val="17202A"/>
+                </a:solidFill>
+              </a:defRPr>
+            </a:pPr>
+            <a:r>
+              <a:t>A6: python -m src.experiments.run_p1_spark_parallelism --mlflow</a:t>
+            </a:r>
+          </a:p>
+          <a:p>
+            <a:pPr>
+              <a:lnSpc>
+                <a:spcPct val="110000"/>
+              </a:lnSpc>
+              <a:spcAft>
+                <a:spcPts val="700"/>
+              </a:spcAft>
+              <a:defRPr sz="1350">
+                <a:solidFill>
+                  <a:srgbClr val="17202A"/>
+                </a:solidFill>
+              </a:defRPr>
+            </a:pPr>
+            <a:r>
+              <a:t>Figures: python -m src.experiments.run_p1_visualizations</a:t>
+            </a:r>
+          </a:p>
+          <a:p>
+            <a:pPr>
+              <a:lnSpc>
+                <a:spcPct val="110000"/>
+              </a:lnSpc>
+              <a:spcAft>
+                <a:spcPts val="700"/>
+              </a:spcAft>
+              <a:defRPr sz="1350">
+                <a:solidFill>
+                  <a:srgbClr val="17202A"/>
+                </a:solidFill>
+              </a:defRPr>
+            </a:pPr>
+            <a:r>
+              <a:t>PPT: python scripts/build_p1_midterm_ppt.py</a:t>
+            </a:r>
+          </a:p>
+        </p:txBody>
+      </p:sp>
+      <p:sp>
+        <p:nvSpPr>
+          <p:cNvPr id="5" name="TextBox 4"/>
+          <p:cNvSpPr txBox="1"/>
+          <p:nvPr/>
+        </p:nvSpPr>
+        <p:spPr>
+          <a:xfrm>
+            <a:off x="6400800" y="1143000"/>
+            <a:ext cx="4983480" cy="4526280"/>
+          </a:xfrm>
+          <a:prstGeom prst="rect">
+            <a:avLst/>
+          </a:prstGeom>
+          <a:noFill/>
+        </p:spPr>
+        <p:txBody>
+          <a:bodyPr wrap="square">
+            <a:spAutoFit/>
+          </a:bodyPr>
+          <a:lstStyle/>
+          <a:p>
+            <a:pPr>
+              <a:lnSpc>
+                <a:spcPct val="110000"/>
+              </a:lnSpc>
+              <a:spcAft>
+                <a:spcPts val="700"/>
+              </a:spcAft>
+              <a:defRPr sz="1450">
+                <a:solidFill>
+                  <a:srgbClr val="5F6B7A"/>
+                </a:solidFill>
+              </a:defRPr>
+            </a:pPr>
+            <a:r>
+              <a:t>报告:00_docs/P1_MIDTERM_REPORT.md</a:t>
+            </a:r>
+          </a:p>
+          <a:p>
+            <a:pPr>
+              <a:lnSpc>
+                <a:spcPct val="110000"/>
+              </a:lnSpc>
+              <a:spcAft>
+                <a:spcPts val="700"/>
+              </a:spcAft>
+              <a:defRPr sz="1450">
+                <a:solidFill>
+                  <a:srgbClr val="5F6B7A"/>
+                </a:solidFill>
+              </a:defRPr>
+            </a:pPr>
+            <a:r>
+              <a:t>讲稿:00_docs/P1_MIDTERM_TALK_TRACK.md</a:t>
+            </a:r>
+          </a:p>
+          <a:p>
+            <a:pPr>
+              <a:lnSpc>
+                <a:spcPct val="110000"/>
+              </a:lnSpc>
+              <a:spcAft>
+                <a:spcPts val="700"/>
+              </a:spcAft>
+              <a:defRPr sz="1450">
+                <a:solidFill>
+                  <a:srgbClr val="5F6B7A"/>
+                </a:solidFill>
+              </a:defRPr>
+            </a:pPr>
+            <a:r>
+              <a:t>Q&amp;A:00_docs/P1_MIDTERM_QA.md</a:t>
+            </a:r>
+          </a:p>
+          <a:p>
+            <a:pPr>
+              <a:lnSpc>
+                <a:spcPct val="110000"/>
+              </a:lnSpc>
+              <a:spcAft>
+                <a:spcPts val="700"/>
+              </a:spcAft>
+              <a:defRPr sz="1450">
+                <a:solidFill>
+                  <a:srgbClr val="5F6B7A"/>
+                </a:solidFill>
+              </a:defRPr>
+            </a:pPr>
+            <a:r>
+              <a:t>PPT:reports/p1_midterm_slides.pptx</a:t>
+            </a:r>
+          </a:p>
+          <a:p>
+            <a:pPr>
+              <a:lnSpc>
+                <a:spcPct val="110000"/>
+              </a:lnSpc>
+              <a:spcAft>
+                <a:spcPts val="700"/>
+              </a:spcAft>
+              <a:defRPr sz="1450">
+                <a:solidFill>
+                  <a:srgbClr val="5F6B7A"/>
+                </a:solidFill>
+              </a:defRPr>
+            </a:pPr>
+            <a:r>
+              <a:t>HTML:reports/p1_midterm_explainer.html</a:t>
+            </a:r>
+          </a:p>
+          <a:p>
+            <a:pPr>
+              <a:lnSpc>
+                <a:spcPct val="110000"/>
+              </a:lnSpc>
+              <a:spcAft>
+                <a:spcPts val="700"/>
+              </a:spcAft>
+              <a:defRPr sz="1450">
+                <a:solidFill>
+                  <a:srgbClr val="5F6B7A"/>
+                </a:solidFill>
+              </a:defRPr>
+            </a:pPr>
+            <a:r>
+              <a:t>图件:reports/figures/</a:t>
+            </a:r>
+          </a:p>
+        </p:txBody>
+      </p:sp>
+      <p:sp>
+        <p:nvSpPr>
+          <p:cNvPr id="6" name="TextBox 5"/>
+          <p:cNvSpPr txBox="1"/>
+          <p:nvPr/>
+        </p:nvSpPr>
+        <p:spPr>
+          <a:xfrm>
+            <a:off x="502920" y="6510528"/>
+            <a:ext cx="4754880" cy="201168"/>
+          </a:xfrm>
+          <a:prstGeom prst="rect">
+            <a:avLst/>
+          </a:prstGeom>
+          <a:noFill/>
+        </p:spPr>
+        <p:txBody>
+          <a:bodyPr wrap="none">
+            <a:spAutoFit/>
+          </a:bodyPr>
+          <a:lstStyle/>
+          <a:p>
+            <a:r>
+              <a:rPr sz="850" b="0">
+                <a:solidFill>
+                  <a:srgbClr val="5F6B7A"/>
+                </a:solidFill>
+              </a:rPr>
+              <a:t>MLsystem P1 midterm | PIU multi-system comparison</a:t>
+            </a:r>
+          </a:p>
+        </p:txBody>
+      </p:sp>
+      <p:sp>
+        <p:nvSpPr>
+          <p:cNvPr id="7" name="TextBox 6"/>
+          <p:cNvSpPr txBox="1"/>
+          <p:nvPr/>
+        </p:nvSpPr>
+        <p:spPr>
+          <a:xfrm>
+            <a:off x="11201400" y="6510528"/>
+            <a:ext cx="502920" cy="201168"/>
+          </a:xfrm>
+          <a:prstGeom prst="rect">
+            <a:avLst/>
+          </a:prstGeom>
+          <a:noFill/>
+        </p:spPr>
+        <p:txBody>
+          <a:bodyPr wrap="none">
+            <a:spAutoFit/>
+          </a:bodyPr>
+          <a:lstStyle/>
+          <a:p>
+            <a:pPr algn="r"/>
+            <a:r>
+              <a:rPr sz="850" b="0">
+                <a:solidFill>
+                  <a:srgbClr val="5F6B7A"/>
+                </a:solidFill>
+              </a:rPr>
+              <a:t>13</a:t>
             </a:r>
           </a:p>
         </p:txBody>

</xml_diff>